<commit_message>
sd-11-012, sd-11-014: explain convergent encryption as deduplication, fix the retry fan-out count
Co-Authored-By: Claude Sonnet 5.5 <noreply@anthropic.com>
Claude-Session: https://claude.ai/code/session_0121Z35eF2EmPsW9asDgHWsZ
</commit_message>
<xml_diff>
--- a/system-design-101/vi/lessons/sd-11-012/slides/sd-11-012.pptx
+++ b/system-design-101/vi/lessons/sd-11-012/slides/sd-11-012.pptx
@@ -8933,6 +8933,50 @@
               <a:buNone/>
             </a:pPr>
             <a:r>
+              <a:rPr lang="en-US" sz="2550" dirty="0" spc="1" kern="0">
+                <a:solidFill>
+                  <a:srgbClr val="14161C"/>
+                </a:solidFill>
+                <a:latin typeface="Be Vietnam Pro" pitchFamily="34" charset="0"/>
+                <a:ea typeface="Be Vietnam Pro" pitchFamily="34" charset="-122"/>
+                <a:cs typeface="Be Vietnam Pro" pitchFamily="34" charset="-120"/>
+              </a:rPr>
+              <a:t>Mã</a:t>
+            </a:r>
+            <a:r>
+              <a:rPr lang="en-US" sz="2550" dirty="0" spc="-4" kern="0">
+                <a:solidFill>
+                  <a:srgbClr val="14161C"/>
+                </a:solidFill>
+                <a:latin typeface="Be Vietnam Pro" pitchFamily="34" charset="0"/>
+                <a:ea typeface="Be Vietnam Pro" pitchFamily="34" charset="-122"/>
+                <a:cs typeface="Be Vietnam Pro" pitchFamily="34" charset="-120"/>
+              </a:rPr>
+              <a:t> hóa</a:t>
+            </a:r>
+            <a:r>
+              <a:rPr lang="en-US" sz="2550" dirty="0" spc="-1" kern="0">
+                <a:solidFill>
+                  <a:srgbClr val="14161C"/>
+                </a:solidFill>
+                <a:latin typeface="Be Vietnam Pro" pitchFamily="34" charset="0"/>
+                <a:ea typeface="Be Vietnam Pro" pitchFamily="34" charset="-122"/>
+                <a:cs typeface="Be Vietnam Pro" pitchFamily="34" charset="-120"/>
+              </a:rPr>
+              <a:t> theo nội</a:t>
+            </a:r>
+            <a:r>
+              <a:rPr lang="en-US" sz="2550" dirty="0" spc="1" kern="0">
+                <a:solidFill>
+                  <a:srgbClr val="14161C"/>
+                </a:solidFill>
+                <a:latin typeface="Be Vietnam Pro" pitchFamily="34" charset="0"/>
+                <a:ea typeface="Be Vietnam Pro" pitchFamily="34" charset="-122"/>
+                <a:cs typeface="Be Vietnam Pro" pitchFamily="34" charset="-120"/>
+              </a:rPr>
+              <a:t> dung:</a:t>
+            </a:r>
+            <a:r>
               <a:rPr lang="en-US" sz="2550" dirty="0" spc="3" kern="0">
                 <a:solidFill>
                   <a:srgbClr val="14161C"/>
@@ -8941,10 +8985,10 @@
                 <a:ea typeface="Be Vietnam Pro" pitchFamily="34" charset="-122"/>
                 <a:cs typeface="Be Vietnam Pro" pitchFamily="34" charset="-120"/>
               </a:rPr>
-              <a:t>Bảo</a:t>
-            </a:r>
-            <a:r>
-              <a:rPr lang="en-US" sz="2550" dirty="0" spc="-19" kern="0">
+              <a:t> mẩu</a:t>
+            </a:r>
+            <a:r>
+              <a:rPr lang="en-US" sz="2550" dirty="0" spc="0" kern="0">
                 <a:solidFill>
                   <a:srgbClr val="14161C"/>
                 </a:solidFill>
@@ -8952,10 +8996,10 @@
                 <a:ea typeface="Be Vietnam Pro" pitchFamily="34" charset="-122"/>
                 <a:cs typeface="Be Vietnam Pro" pitchFamily="34" charset="-120"/>
               </a:rPr>
-              <a:t> vệ</a:t>
-            </a:r>
-            <a:r>
-              <a:rPr lang="en-US" sz="2550" dirty="0" spc="-2" kern="0">
+              <a:t> giống nhau</a:t>
+            </a:r>
+            <a:r>
+              <a:rPr lang="en-US" sz="2550" dirty="0" spc="1" kern="0">
                 <a:solidFill>
                   <a:srgbClr val="14161C"/>
                 </a:solidFill>
@@ -8963,10 +9007,10 @@
                 <a:ea typeface="Be Vietnam Pro" pitchFamily="34" charset="-122"/>
                 <a:cs typeface="Be Vietnam Pro" pitchFamily="34" charset="-120"/>
               </a:rPr>
-              <a:t> dữ</a:t>
-            </a:r>
-            <a:r>
-              <a:rPr lang="en-US" sz="2550" dirty="0" spc="1" kern="0">
+              <a:t> chỉ</a:t>
+            </a:r>
+            <a:r>
+              <a:rPr lang="en-US" sz="2550" dirty="0" spc="19" kern="0">
                 <a:solidFill>
                   <a:srgbClr val="14161C"/>
                 </a:solidFill>
@@ -8974,10 +9018,10 @@
                 <a:ea typeface="Be Vietnam Pro" pitchFamily="34" charset="-122"/>
                 <a:cs typeface="Be Vietnam Pro" pitchFamily="34" charset="-120"/>
               </a:rPr>
-              <a:t> liệu</a:t>
-            </a:r>
-            <a:r>
-              <a:rPr lang="en-US" sz="2550" dirty="0" spc="-1" kern="0">
+              <a:t> lưu</a:t>
+            </a:r>
+            <a:r>
+              <a:rPr lang="en-US" sz="2550" dirty="0" spc="-5" kern="0">
                 <a:solidFill>
                   <a:srgbClr val="14161C"/>
                 </a:solidFill>
@@ -8985,10 +9029,10 @@
                 <a:ea typeface="Be Vietnam Pro" pitchFamily="34" charset="-122"/>
                 <a:cs typeface="Be Vietnam Pro" pitchFamily="34" charset="-120"/>
               </a:rPr>
-              <a:t> dùng</a:t>
-            </a:r>
-            <a:r>
-              <a:rPr lang="en-US" sz="2550" dirty="0" spc="1" kern="0">
+              <a:t> một</a:t>
+            </a:r>
+            <a:r>
+              <a:rPr lang="en-US" sz="2550" dirty="0" spc="0" kern="0">
                 <a:solidFill>
                   <a:srgbClr val="14161C"/>
                 </a:solidFill>
@@ -8996,51 +9040,7 @@
                 <a:ea typeface="Be Vietnam Pro" pitchFamily="34" charset="-122"/>
                 <a:cs typeface="Be Vietnam Pro" pitchFamily="34" charset="-120"/>
               </a:rPr>
-              <a:t> chung,</a:t>
-            </a:r>
-            <a:r>
-              <a:rPr lang="en-US" sz="2550" dirty="0" spc="0" kern="0">
-                <a:solidFill>
-                  <a:srgbClr val="14161C"/>
-                </a:solidFill>
-                <a:latin typeface="Be Vietnam Pro" pitchFamily="34" charset="0"/>
-                <a:ea typeface="Be Vietnam Pro" pitchFamily="34" charset="-122"/>
-                <a:cs typeface="Be Vietnam Pro" pitchFamily="34" charset="-120"/>
-              </a:rPr>
-              <a:t> mã</a:t>
-            </a:r>
-            <a:r>
-              <a:rPr lang="en-US" sz="2550" dirty="0" spc="-2" kern="0">
-                <a:solidFill>
-                  <a:srgbClr val="14161C"/>
-                </a:solidFill>
-                <a:latin typeface="Be Vietnam Pro" pitchFamily="34" charset="0"/>
-                <a:ea typeface="Be Vietnam Pro" pitchFamily="34" charset="-122"/>
-                <a:cs typeface="Be Vietnam Pro" pitchFamily="34" charset="-120"/>
-              </a:rPr>
-              <a:t> băm</a:t>
-            </a:r>
-            <a:r>
-              <a:rPr lang="en-US" sz="2550" dirty="0" spc="-3" kern="0">
-                <a:solidFill>
-                  <a:srgbClr val="14161C"/>
-                </a:solidFill>
-                <a:latin typeface="Be Vietnam Pro" pitchFamily="34" charset="0"/>
-                <a:ea typeface="Be Vietnam Pro" pitchFamily="34" charset="-122"/>
-                <a:cs typeface="Be Vietnam Pro" pitchFamily="34" charset="-120"/>
-              </a:rPr>
-              <a:t> bền</a:t>
-            </a:r>
-            <a:r>
-              <a:rPr lang="en-US" sz="2550" dirty="0" spc="-1" kern="0">
-                <a:solidFill>
-                  <a:srgbClr val="14161C"/>
-                </a:solidFill>
-                <a:latin typeface="Be Vietnam Pro" pitchFamily="34" charset="0"/>
-                <a:ea typeface="Be Vietnam Pro" pitchFamily="34" charset="-122"/>
-                <a:cs typeface="Be Vietnam Pro" pitchFamily="34" charset="-120"/>
-              </a:rPr>
-              <a:t> hơn</a:t>
+              <a:t> lần</a:t>
             </a:r>
             <a:endParaRPr lang="en-US" sz="2550" dirty="0"/>
           </a:p>

</xml_diff>

<commit_message>
sd-11-012, sd-11-015: limit component-storage savings to code loading and environment creation, retitle the paper list
Co-Authored-By: Claude Sonnet 5.5 <noreply@anthropic.com>
Claude-Session: https://claude.ai/code/session_0121Z35eF2EmPsW9asDgHWsZ
</commit_message>
<xml_diff>
--- a/system-design-101/vi/lessons/sd-11-012/slides/sd-11-012.pptx
+++ b/system-design-101/vi/lessons/sd-11-012/slides/sd-11-012.pptx
@@ -8519,17 +8519,17 @@
           <a:ln/>
         </p:spPr>
         <p:txBody>
-          <a:bodyPr wrap="square" lIns="0" tIns="59150" rIns="0" bIns="-59150" rtlCol="0" anchor="ctr"/>
+          <a:bodyPr wrap="square" lIns="0" tIns="52705" rIns="0" bIns="-52705" rtlCol="0" anchor="ctr"/>
           <a:lstStyle/>
           <a:p>
             <a:pPr algn="l" indent="0" marL="0">
               <a:lnSpc>
-                <a:spcPts val="7245"/>
+                <a:spcPts val="6458"/>
               </a:lnSpc>
               <a:buNone/>
             </a:pPr>
             <a:r>
-              <a:rPr lang="en-US" sz="6900" dirty="0" spc="2" kern="0">
+              <a:rPr lang="en-US" sz="6150" dirty="0" spc="4" kern="0">
                 <a:solidFill>
                   <a:srgbClr val="14161C"/>
                 </a:solidFill>
@@ -8537,10 +8537,10 @@
                 <a:ea typeface="Bricolage Grotesque ExtraBold" pitchFamily="34" charset="-122"/>
                 <a:cs typeface="Bricolage Grotesque ExtraBold" pitchFamily="34" charset="-120"/>
               </a:rPr>
-              <a:t>Ít</a:t>
-            </a:r>
-            <a:r>
-              <a:rPr lang="en-US" sz="6900" dirty="0" spc="-2" kern="0">
+              <a:t>Nạp</a:t>
+            </a:r>
+            <a:r>
+              <a:rPr lang="en-US" sz="6150" dirty="0" spc="1" kern="0">
                 <a:solidFill>
                   <a:srgbClr val="14161C"/>
                 </a:solidFill>
@@ -8548,10 +8548,10 @@
                 <a:ea typeface="Bricolage Grotesque ExtraBold" pitchFamily="34" charset="-122"/>
                 <a:cs typeface="Bricolage Grotesque ExtraBold" pitchFamily="34" charset="-120"/>
               </a:rPr>
-              <a:t> dữ</a:t>
-            </a:r>
-            <a:r>
-              <a:rPr lang="en-US" sz="6900" dirty="0" spc="7" kern="0">
+              <a:t> mã</a:t>
+            </a:r>
+            <a:r>
+              <a:rPr lang="en-US" sz="6150" dirty="0" spc="-9" kern="0">
                 <a:solidFill>
                   <a:srgbClr val="14161C"/>
                 </a:solidFill>
@@ -8559,10 +8559,10 @@
                 <a:ea typeface="Bricolage Grotesque ExtraBold" pitchFamily="34" charset="-122"/>
                 <a:cs typeface="Bricolage Grotesque ExtraBold" pitchFamily="34" charset="-120"/>
               </a:rPr>
-              <a:t> liệu</a:t>
-            </a:r>
-            <a:r>
-              <a:rPr lang="en-US" sz="6900" dirty="0" spc="5" kern="0">
+              <a:t> nhẹ,</a:t>
+            </a:r>
+            <a:r>
+              <a:rPr lang="en-US" sz="6150" dirty="0" spc="-4" kern="0">
                 <a:solidFill>
                   <a:srgbClr val="14161C"/>
                 </a:solidFill>
@@ -8570,10 +8570,10 @@
                 <a:ea typeface="Bricolage Grotesque ExtraBold" pitchFamily="34" charset="-122"/>
                 <a:cs typeface="Bricolage Grotesque ExtraBold" pitchFamily="34" charset="-120"/>
               </a:rPr>
-              <a:t> phải</a:t>
-            </a:r>
-            <a:r>
-              <a:rPr lang="en-US" sz="6900" dirty="0" spc="3" kern="0">
+              <a:t> tạo</a:t>
+            </a:r>
+            <a:r>
+              <a:rPr lang="en-US" sz="6150" dirty="0" spc="0" kern="0">
                 <a:solidFill>
                   <a:srgbClr val="14161C"/>
                 </a:solidFill>
@@ -8581,10 +8581,10 @@
                 <a:ea typeface="Bricolage Grotesque ExtraBold" pitchFamily="34" charset="-122"/>
                 <a:cs typeface="Bricolage Grotesque ExtraBold" pitchFamily="34" charset="-120"/>
               </a:rPr>
-              <a:t> chuyển</a:t>
-            </a:r>
-            <a:r>
-              <a:rPr lang="en-US" sz="6900" dirty="0" spc="-43" kern="0">
+              <a:t> môi</a:t>
+            </a:r>
+            <a:r>
+              <a:rPr lang="en-US" sz="6150" dirty="0" spc="-52" kern="0">
                 <a:solidFill>
                   <a:srgbClr val="14161C"/>
                 </a:solidFill>
@@ -8592,9 +8592,20 @@
                 <a:ea typeface="Bricolage Grotesque ExtraBold" pitchFamily="34" charset="-122"/>
                 <a:cs typeface="Bricolage Grotesque ExtraBold" pitchFamily="34" charset="-120"/>
               </a:rPr>
-              <a:t> hơn</a:t>
-            </a:r>
-            <a:endParaRPr lang="en-US" sz="6900" dirty="0"/>
+              <a:t> trường</a:t>
+            </a:r>
+            <a:r>
+              <a:rPr lang="en-US" sz="6150" dirty="0" spc="-3" kern="0">
+                <a:solidFill>
+                  <a:srgbClr val="14161C"/>
+                </a:solidFill>
+                <a:latin typeface="Bricolage Grotesque ExtraBold" pitchFamily="34" charset="0"/>
+                <a:ea typeface="Bricolage Grotesque ExtraBold" pitchFamily="34" charset="-122"/>
+                <a:cs typeface="Bricolage Grotesque ExtraBold" pitchFamily="34" charset="-120"/>
+              </a:rPr>
+              <a:t> nhanh</a:t>
+            </a:r>
+            <a:endParaRPr lang="en-US" sz="6150" dirty="0"/>
           </a:p>
         </p:txBody>
       </p:sp>
@@ -9154,10 +9165,32 @@
                 <a:ea typeface="Be Vietnam Pro" pitchFamily="34" charset="-122"/>
                 <a:cs typeface="Be Vietnam Pro" pitchFamily="34" charset="-120"/>
               </a:rPr>
+              <a:t> khi</a:t>
+            </a:r>
+            <a:r>
+              <a:rPr lang="en-US" sz="2550" dirty="0" spc="-12" kern="0">
+                <a:solidFill>
+                  <a:srgbClr val="14161C"/>
+                </a:solidFill>
+                <a:latin typeface="Be Vietnam Pro" pitchFamily="34" charset="0"/>
+                <a:ea typeface="Be Vietnam Pro" pitchFamily="34" charset="-122"/>
+                <a:cs typeface="Be Vietnam Pro" pitchFamily="34" charset="-120"/>
+              </a:rPr>
+              <a:t> tạo</a:t>
+            </a:r>
+            <a:r>
+              <a:rPr lang="en-US" sz="2550" dirty="0" spc="0" kern="0">
+                <a:solidFill>
+                  <a:srgbClr val="14161C"/>
+                </a:solidFill>
+                <a:latin typeface="Be Vietnam Pro" pitchFamily="34" charset="0"/>
+                <a:ea typeface="Be Vietnam Pro" pitchFamily="34" charset="-122"/>
+                <a:cs typeface="Be Vietnam Pro" pitchFamily="34" charset="-120"/>
+              </a:rPr>
               <a:t> môi</a:t>
             </a:r>
             <a:r>
-              <a:rPr lang="en-US" sz="2550" dirty="0" spc="4" kern="0">
+              <a:rPr lang="en-US" sz="2550" dirty="0" spc="5" kern="0">
                 <a:solidFill>
                   <a:srgbClr val="14161C"/>
                 </a:solidFill>
@@ -9165,10 +9198,21 @@
                 <a:ea typeface="Be Vietnam Pro" pitchFamily="34" charset="-122"/>
                 <a:cs typeface="Be Vietnam Pro" pitchFamily="34" charset="-120"/>
               </a:rPr>
-              <a:t> trường,</a:t>
-            </a:r>
-            <a:r>
-              <a:rPr lang="en-US" sz="2550" dirty="0" spc="-2" kern="0">
+              <a:t> trường</a:t>
+            </a:r>
+            <a:r>
+              <a:rPr lang="en-US" sz="2550" dirty="0" spc="0" kern="0">
+                <a:solidFill>
+                  <a:srgbClr val="14161C"/>
+                </a:solidFill>
+                <a:latin typeface="Be Vietnam Pro" pitchFamily="34" charset="0"/>
+                <a:ea typeface="Be Vietnam Pro" pitchFamily="34" charset="-122"/>
+                <a:cs typeface="Be Vietnam Pro" pitchFamily="34" charset="-120"/>
+              </a:rPr>
+              <a:t> mới,</a:t>
+            </a:r>
+            <a:r>
+              <a:rPr lang="en-US" sz="2550" dirty="0" spc="-3" kern="0">
                 <a:solidFill>
                   <a:srgbClr val="14161C"/>
                 </a:solidFill>
@@ -9217,264 +9261,14 @@
       </p:sp>
       <p:sp>
         <p:nvSpPr>
-          <p:cNvPr id="13" name="Shape 11"/>
-          <p:cNvSpPr/>
-          <p:nvPr/>
-        </p:nvSpPr>
-        <p:spPr>
-          <a:xfrm>
-            <a:off x="933450" y="9429750"/>
-            <a:ext cx="114300" cy="114300"/>
-          </a:xfrm>
-          <a:prstGeom prst="ellipse">
-            <a:avLst/>
-          </a:prstGeom>
-          <a:solidFill>
-            <a:srgbClr val="14161C"/>
-          </a:solidFill>
-          <a:ln w="19050">
-            <a:solidFill>
-              <a:srgbClr val="14161C"/>
-            </a:solidFill>
-            <a:prstDash val="solid"/>
-          </a:ln>
-        </p:spPr>
-      </p:sp>
-      <p:sp>
-        <p:nvSpPr>
-          <p:cNvPr id="14" name="Shape 12"/>
-          <p:cNvSpPr/>
-          <p:nvPr/>
-        </p:nvSpPr>
-        <p:spPr>
-          <a:xfrm>
-            <a:off x="1257300" y="9429750"/>
-            <a:ext cx="114300" cy="114300"/>
-          </a:xfrm>
-          <a:prstGeom prst="ellipse">
-            <a:avLst/>
-          </a:prstGeom>
-          <a:solidFill>
-            <a:srgbClr val="14161C"/>
-          </a:solidFill>
-          <a:ln w="19050">
-            <a:solidFill>
-              <a:srgbClr val="14161C"/>
-            </a:solidFill>
-            <a:prstDash val="solid"/>
-          </a:ln>
-        </p:spPr>
-      </p:sp>
-      <p:sp>
-        <p:nvSpPr>
-          <p:cNvPr id="15" name="Shape 13"/>
-          <p:cNvSpPr/>
-          <p:nvPr/>
-        </p:nvSpPr>
-        <p:spPr>
-          <a:xfrm>
-            <a:off x="1581150" y="9429750"/>
-            <a:ext cx="114300" cy="114300"/>
-          </a:xfrm>
-          <a:prstGeom prst="ellipse">
-            <a:avLst/>
-          </a:prstGeom>
-          <a:solidFill>
-            <a:srgbClr val="14161C"/>
-          </a:solidFill>
-          <a:ln w="19050">
-            <a:solidFill>
-              <a:srgbClr val="14161C"/>
-            </a:solidFill>
-            <a:prstDash val="solid"/>
-          </a:ln>
-        </p:spPr>
-      </p:sp>
-      <p:sp>
-        <p:nvSpPr>
-          <p:cNvPr id="16" name="Shape 14"/>
-          <p:cNvSpPr/>
-          <p:nvPr/>
-        </p:nvSpPr>
-        <p:spPr>
-          <a:xfrm>
-            <a:off x="1905000" y="9429750"/>
-            <a:ext cx="114300" cy="114300"/>
-          </a:xfrm>
-          <a:prstGeom prst="ellipse">
-            <a:avLst/>
-          </a:prstGeom>
-          <a:solidFill>
-            <a:srgbClr val="14161C"/>
-          </a:solidFill>
-          <a:ln w="19050">
-            <a:solidFill>
-              <a:srgbClr val="14161C"/>
-            </a:solidFill>
-            <a:prstDash val="solid"/>
-          </a:ln>
-        </p:spPr>
-      </p:sp>
-      <p:sp>
-        <p:nvSpPr>
-          <p:cNvPr id="17" name="Shape 15"/>
-          <p:cNvSpPr/>
-          <p:nvPr/>
-        </p:nvSpPr>
-        <p:spPr>
-          <a:xfrm>
-            <a:off x="2228850" y="9429750"/>
-            <a:ext cx="114300" cy="114300"/>
-          </a:xfrm>
-          <a:prstGeom prst="ellipse">
-            <a:avLst/>
-          </a:prstGeom>
-          <a:solidFill>
-            <a:srgbClr val="14161C"/>
-          </a:solidFill>
-          <a:ln w="19050">
-            <a:solidFill>
-              <a:srgbClr val="14161C"/>
-            </a:solidFill>
-            <a:prstDash val="solid"/>
-          </a:ln>
-        </p:spPr>
-      </p:sp>
-      <p:sp>
-        <p:nvSpPr>
-          <p:cNvPr id="18" name="Shape 16"/>
-          <p:cNvSpPr/>
-          <p:nvPr/>
-        </p:nvSpPr>
-        <p:spPr>
-          <a:xfrm>
-            <a:off x="2514600" y="9391650"/>
-            <a:ext cx="190500" cy="190500"/>
-          </a:xfrm>
-          <a:prstGeom prst="ellipse">
-            <a:avLst/>
-          </a:prstGeom>
-          <a:solidFill>
-            <a:srgbClr val="FF6A4D"/>
-          </a:solidFill>
-          <a:ln w="19050">
-            <a:solidFill>
-              <a:srgbClr val="FF6A4D"/>
-            </a:solidFill>
-            <a:prstDash val="solid"/>
-          </a:ln>
-        </p:spPr>
-      </p:sp>
-      <p:sp>
-        <p:nvSpPr>
-          <p:cNvPr id="19" name="Shape 17"/>
-          <p:cNvSpPr/>
-          <p:nvPr/>
-        </p:nvSpPr>
-        <p:spPr>
-          <a:xfrm>
-            <a:off x="2876550" y="9429750"/>
-            <a:ext cx="114300" cy="114300"/>
-          </a:xfrm>
-          <a:prstGeom prst="ellipse">
-            <a:avLst/>
-          </a:prstGeom>
-          <a:solidFill>
-            <a:srgbClr val="F3EEE3"/>
-          </a:solidFill>
-          <a:ln w="19050">
-            <a:solidFill>
-              <a:srgbClr val="8A867C"/>
-            </a:solidFill>
-            <a:prstDash val="solid"/>
-          </a:ln>
-        </p:spPr>
-      </p:sp>
-      <p:sp>
-        <p:nvSpPr>
-          <p:cNvPr id="20" name="Shape 18"/>
-          <p:cNvSpPr/>
-          <p:nvPr/>
-        </p:nvSpPr>
-        <p:spPr>
-          <a:xfrm>
-            <a:off x="3200400" y="9429750"/>
-            <a:ext cx="114300" cy="114300"/>
-          </a:xfrm>
-          <a:prstGeom prst="ellipse">
-            <a:avLst/>
-          </a:prstGeom>
-          <a:solidFill>
-            <a:srgbClr val="F3EEE3"/>
-          </a:solidFill>
-          <a:ln w="19050">
-            <a:solidFill>
-              <a:srgbClr val="8A867C"/>
-            </a:solidFill>
-            <a:prstDash val="solid"/>
-          </a:ln>
-        </p:spPr>
-      </p:sp>
-      <p:sp>
-        <p:nvSpPr>
-          <p:cNvPr id="21" name="Shape 19"/>
-          <p:cNvSpPr/>
-          <p:nvPr/>
-        </p:nvSpPr>
-        <p:spPr>
-          <a:xfrm>
-            <a:off x="3524250" y="9429750"/>
-            <a:ext cx="114300" cy="114300"/>
-          </a:xfrm>
-          <a:prstGeom prst="ellipse">
-            <a:avLst/>
-          </a:prstGeom>
-          <a:solidFill>
-            <a:srgbClr val="F3EEE3"/>
-          </a:solidFill>
-          <a:ln w="19050">
-            <a:solidFill>
-              <a:srgbClr val="8A867C"/>
-            </a:solidFill>
-            <a:prstDash val="solid"/>
-          </a:ln>
-        </p:spPr>
-      </p:sp>
-      <p:sp>
-        <p:nvSpPr>
-          <p:cNvPr id="22" name="Shape 20"/>
-          <p:cNvSpPr/>
-          <p:nvPr/>
-        </p:nvSpPr>
-        <p:spPr>
-          <a:xfrm>
-            <a:off x="3848100" y="9429750"/>
-            <a:ext cx="114300" cy="114300"/>
-          </a:xfrm>
-          <a:prstGeom prst="ellipse">
-            <a:avLst/>
-          </a:prstGeom>
-          <a:solidFill>
-            <a:srgbClr val="F3EEE3"/>
-          </a:solidFill>
-          <a:ln w="19050">
-            <a:solidFill>
-              <a:srgbClr val="8A867C"/>
-            </a:solidFill>
-            <a:prstDash val="solid"/>
-          </a:ln>
-        </p:spPr>
-      </p:sp>
-      <p:sp>
-        <p:nvSpPr>
-          <p:cNvPr id="23" name="Text 21"/>
-          <p:cNvSpPr/>
-          <p:nvPr/>
-        </p:nvSpPr>
-        <p:spPr>
-          <a:xfrm>
-            <a:off x="914400" y="9715500"/>
-            <a:ext cx="6667500" cy="285750"/>
+          <p:cNvPr id="13" name="Text 11"/>
+          <p:cNvSpPr/>
+          <p:nvPr/>
+        </p:nvSpPr>
+        <p:spPr>
+          <a:xfrm>
+            <a:off x="914400" y="8191500"/>
+            <a:ext cx="16459200" cy="476250"/>
           </a:xfrm>
           <a:prstGeom prst="rect">
             <a:avLst/>
@@ -9490,6 +9284,438 @@
               <a:buNone/>
             </a:pPr>
             <a:r>
+              <a:rPr lang="en-US" sz="2250" dirty="0" spc="5" kern="0">
+                <a:solidFill>
+                  <a:srgbClr val="3A3F52"/>
+                </a:solidFill>
+                <a:latin typeface="Be Vietnam Pro" pitchFamily="34" charset="0"/>
+                <a:ea typeface="Be Vietnam Pro" pitchFamily="34" charset="-122"/>
+                <a:cs typeface="Be Vietnam Pro" pitchFamily="34" charset="-120"/>
+              </a:rPr>
+              <a:t>Áp</a:t>
+            </a:r>
+            <a:r>
+              <a:rPr lang="en-US" sz="2250" dirty="0" spc="3" kern="0">
+                <a:solidFill>
+                  <a:srgbClr val="3A3F52"/>
+                </a:solidFill>
+                <a:latin typeface="Be Vietnam Pro" pitchFamily="34" charset="0"/>
+                <a:ea typeface="Be Vietnam Pro" pitchFamily="34" charset="-122"/>
+                <a:cs typeface="Be Vietnam Pro" pitchFamily="34" charset="-120"/>
+              </a:rPr>
+              <a:t> dụng</a:t>
+            </a:r>
+            <a:r>
+              <a:rPr lang="en-US" sz="2250" dirty="0" spc="0" kern="0">
+                <a:solidFill>
+                  <a:srgbClr val="3A3F52"/>
+                </a:solidFill>
+                <a:latin typeface="Be Vietnam Pro" pitchFamily="34" charset="0"/>
+                <a:ea typeface="Be Vietnam Pro" pitchFamily="34" charset="-122"/>
+                <a:cs typeface="Be Vietnam Pro" pitchFamily="34" charset="-120"/>
+              </a:rPr>
+              <a:t> cho</a:t>
+            </a:r>
+            <a:r>
+              <a:rPr lang="en-US" sz="2250" dirty="0" spc="-1" kern="0">
+                <a:solidFill>
+                  <a:srgbClr val="3A3F52"/>
+                </a:solidFill>
+                <a:latin typeface="Be Vietnam Pro" pitchFamily="34" charset="0"/>
+                <a:ea typeface="Be Vietnam Pro" pitchFamily="34" charset="-122"/>
+                <a:cs typeface="Be Vietnam Pro" pitchFamily="34" charset="-120"/>
+              </a:rPr>
+              <a:t> mã</a:t>
+            </a:r>
+            <a:r>
+              <a:rPr lang="en-US" sz="2250" dirty="0" spc="15" kern="0">
+                <a:solidFill>
+                  <a:srgbClr val="3A3F52"/>
+                </a:solidFill>
+                <a:latin typeface="Be Vietnam Pro" pitchFamily="34" charset="0"/>
+                <a:ea typeface="Be Vietnam Pro" pitchFamily="34" charset="-122"/>
+                <a:cs typeface="Be Vietnam Pro" pitchFamily="34" charset="-120"/>
+              </a:rPr>
+              <a:t> đã</a:t>
+            </a:r>
+            <a:r>
+              <a:rPr lang="en-US" sz="2250" dirty="0" spc="17" kern="0">
+                <a:solidFill>
+                  <a:srgbClr val="3A3F52"/>
+                </a:solidFill>
+                <a:latin typeface="Be Vietnam Pro" pitchFamily="34" charset="0"/>
+                <a:ea typeface="Be Vietnam Pro" pitchFamily="34" charset="-122"/>
+                <a:cs typeface="Be Vietnam Pro" pitchFamily="34" charset="-120"/>
+              </a:rPr>
+              <a:t> lưu</a:t>
+            </a:r>
+            <a:r>
+              <a:rPr lang="en-US" sz="2250" dirty="0" spc="-17" kern="0">
+                <a:solidFill>
+                  <a:srgbClr val="3A3F52"/>
+                </a:solidFill>
+                <a:latin typeface="Be Vietnam Pro" pitchFamily="34" charset="0"/>
+                <a:ea typeface="Be Vietnam Pro" pitchFamily="34" charset="-122"/>
+                <a:cs typeface="Be Vietnam Pro" pitchFamily="34" charset="-120"/>
+              </a:rPr>
+              <a:t> và</a:t>
+            </a:r>
+            <a:r>
+              <a:rPr lang="en-US" sz="2250" dirty="0" spc="3" kern="0">
+                <a:solidFill>
+                  <a:srgbClr val="3A3F52"/>
+                </a:solidFill>
+                <a:latin typeface="Be Vietnam Pro" pitchFamily="34" charset="0"/>
+                <a:ea typeface="Be Vietnam Pro" pitchFamily="34" charset="-122"/>
+                <a:cs typeface="Be Vietnam Pro" pitchFamily="34" charset="-120"/>
+              </a:rPr>
+              <a:t> lúc</a:t>
+            </a:r>
+            <a:r>
+              <a:rPr lang="en-US" sz="2250" dirty="0" spc="-12" kern="0">
+                <a:solidFill>
+                  <a:srgbClr val="3A3F52"/>
+                </a:solidFill>
+                <a:latin typeface="Be Vietnam Pro" pitchFamily="34" charset="0"/>
+                <a:ea typeface="Be Vietnam Pro" pitchFamily="34" charset="-122"/>
+                <a:cs typeface="Be Vietnam Pro" pitchFamily="34" charset="-120"/>
+              </a:rPr>
+              <a:t> tạo</a:t>
+            </a:r>
+            <a:r>
+              <a:rPr lang="en-US" sz="2250" dirty="0" spc="0" kern="0">
+                <a:solidFill>
+                  <a:srgbClr val="3A3F52"/>
+                </a:solidFill>
+                <a:latin typeface="Be Vietnam Pro" pitchFamily="34" charset="0"/>
+                <a:ea typeface="Be Vietnam Pro" pitchFamily="34" charset="-122"/>
+                <a:cs typeface="Be Vietnam Pro" pitchFamily="34" charset="-120"/>
+              </a:rPr>
+              <a:t> môi</a:t>
+            </a:r>
+            <a:r>
+              <a:rPr lang="en-US" sz="2250" dirty="0" spc="3" kern="0">
+                <a:solidFill>
+                  <a:srgbClr val="3A3F52"/>
+                </a:solidFill>
+                <a:latin typeface="Be Vietnam Pro" pitchFamily="34" charset="0"/>
+                <a:ea typeface="Be Vietnam Pro" pitchFamily="34" charset="-122"/>
+                <a:cs typeface="Be Vietnam Pro" pitchFamily="34" charset="-120"/>
+              </a:rPr>
+              <a:t> trường,</a:t>
+            </a:r>
+            <a:r>
+              <a:rPr lang="en-US" sz="2250" dirty="0" spc="1" kern="0">
+                <a:solidFill>
+                  <a:srgbClr val="3A3F52"/>
+                </a:solidFill>
+                <a:latin typeface="Be Vietnam Pro" pitchFamily="34" charset="0"/>
+                <a:ea typeface="Be Vietnam Pro" pitchFamily="34" charset="-122"/>
+                <a:cs typeface="Be Vietnam Pro" pitchFamily="34" charset="-120"/>
+              </a:rPr>
+              <a:t> không cho</a:t>
+            </a:r>
+            <a:r>
+              <a:rPr lang="en-US" sz="2250" dirty="0" spc="0" kern="0">
+                <a:solidFill>
+                  <a:srgbClr val="3A3F52"/>
+                </a:solidFill>
+                <a:latin typeface="Be Vietnam Pro" pitchFamily="34" charset="0"/>
+                <a:ea typeface="Be Vietnam Pro" pitchFamily="34" charset="-122"/>
+                <a:cs typeface="Be Vietnam Pro" pitchFamily="34" charset="-120"/>
+              </a:rPr>
+              <a:t> mỗi lần</a:t>
+            </a:r>
+            <a:r>
+              <a:rPr lang="en-US" sz="2250" dirty="0" spc="-8" kern="0">
+                <a:solidFill>
+                  <a:srgbClr val="3A3F52"/>
+                </a:solidFill>
+                <a:latin typeface="Be Vietnam Pro" pitchFamily="34" charset="0"/>
+                <a:ea typeface="Be Vietnam Pro" pitchFamily="34" charset="-122"/>
+                <a:cs typeface="Be Vietnam Pro" pitchFamily="34" charset="-120"/>
+              </a:rPr>
+              <a:t> gọi.</a:t>
+            </a:r>
+            <a:endParaRPr lang="en-US" sz="2250" dirty="0"/>
+          </a:p>
+        </p:txBody>
+      </p:sp>
+      <p:sp>
+        <p:nvSpPr>
+          <p:cNvPr id="14" name="Shape 12"/>
+          <p:cNvSpPr/>
+          <p:nvPr/>
+        </p:nvSpPr>
+        <p:spPr>
+          <a:xfrm>
+            <a:off x="933450" y="9429750"/>
+            <a:ext cx="114300" cy="114300"/>
+          </a:xfrm>
+          <a:prstGeom prst="ellipse">
+            <a:avLst/>
+          </a:prstGeom>
+          <a:solidFill>
+            <a:srgbClr val="14161C"/>
+          </a:solidFill>
+          <a:ln w="19050">
+            <a:solidFill>
+              <a:srgbClr val="14161C"/>
+            </a:solidFill>
+            <a:prstDash val="solid"/>
+          </a:ln>
+        </p:spPr>
+      </p:sp>
+      <p:sp>
+        <p:nvSpPr>
+          <p:cNvPr id="15" name="Shape 13"/>
+          <p:cNvSpPr/>
+          <p:nvPr/>
+        </p:nvSpPr>
+        <p:spPr>
+          <a:xfrm>
+            <a:off x="1257300" y="9429750"/>
+            <a:ext cx="114300" cy="114300"/>
+          </a:xfrm>
+          <a:prstGeom prst="ellipse">
+            <a:avLst/>
+          </a:prstGeom>
+          <a:solidFill>
+            <a:srgbClr val="14161C"/>
+          </a:solidFill>
+          <a:ln w="19050">
+            <a:solidFill>
+              <a:srgbClr val="14161C"/>
+            </a:solidFill>
+            <a:prstDash val="solid"/>
+          </a:ln>
+        </p:spPr>
+      </p:sp>
+      <p:sp>
+        <p:nvSpPr>
+          <p:cNvPr id="16" name="Shape 14"/>
+          <p:cNvSpPr/>
+          <p:nvPr/>
+        </p:nvSpPr>
+        <p:spPr>
+          <a:xfrm>
+            <a:off x="1581150" y="9429750"/>
+            <a:ext cx="114300" cy="114300"/>
+          </a:xfrm>
+          <a:prstGeom prst="ellipse">
+            <a:avLst/>
+          </a:prstGeom>
+          <a:solidFill>
+            <a:srgbClr val="14161C"/>
+          </a:solidFill>
+          <a:ln w="19050">
+            <a:solidFill>
+              <a:srgbClr val="14161C"/>
+            </a:solidFill>
+            <a:prstDash val="solid"/>
+          </a:ln>
+        </p:spPr>
+      </p:sp>
+      <p:sp>
+        <p:nvSpPr>
+          <p:cNvPr id="17" name="Shape 15"/>
+          <p:cNvSpPr/>
+          <p:nvPr/>
+        </p:nvSpPr>
+        <p:spPr>
+          <a:xfrm>
+            <a:off x="1905000" y="9429750"/>
+            <a:ext cx="114300" cy="114300"/>
+          </a:xfrm>
+          <a:prstGeom prst="ellipse">
+            <a:avLst/>
+          </a:prstGeom>
+          <a:solidFill>
+            <a:srgbClr val="14161C"/>
+          </a:solidFill>
+          <a:ln w="19050">
+            <a:solidFill>
+              <a:srgbClr val="14161C"/>
+            </a:solidFill>
+            <a:prstDash val="solid"/>
+          </a:ln>
+        </p:spPr>
+      </p:sp>
+      <p:sp>
+        <p:nvSpPr>
+          <p:cNvPr id="18" name="Shape 16"/>
+          <p:cNvSpPr/>
+          <p:nvPr/>
+        </p:nvSpPr>
+        <p:spPr>
+          <a:xfrm>
+            <a:off x="2228850" y="9429750"/>
+            <a:ext cx="114300" cy="114300"/>
+          </a:xfrm>
+          <a:prstGeom prst="ellipse">
+            <a:avLst/>
+          </a:prstGeom>
+          <a:solidFill>
+            <a:srgbClr val="14161C"/>
+          </a:solidFill>
+          <a:ln w="19050">
+            <a:solidFill>
+              <a:srgbClr val="14161C"/>
+            </a:solidFill>
+            <a:prstDash val="solid"/>
+          </a:ln>
+        </p:spPr>
+      </p:sp>
+      <p:sp>
+        <p:nvSpPr>
+          <p:cNvPr id="19" name="Shape 17"/>
+          <p:cNvSpPr/>
+          <p:nvPr/>
+        </p:nvSpPr>
+        <p:spPr>
+          <a:xfrm>
+            <a:off x="2514600" y="9391650"/>
+            <a:ext cx="190500" cy="190500"/>
+          </a:xfrm>
+          <a:prstGeom prst="ellipse">
+            <a:avLst/>
+          </a:prstGeom>
+          <a:solidFill>
+            <a:srgbClr val="FF6A4D"/>
+          </a:solidFill>
+          <a:ln w="19050">
+            <a:solidFill>
+              <a:srgbClr val="FF6A4D"/>
+            </a:solidFill>
+            <a:prstDash val="solid"/>
+          </a:ln>
+        </p:spPr>
+      </p:sp>
+      <p:sp>
+        <p:nvSpPr>
+          <p:cNvPr id="20" name="Shape 18"/>
+          <p:cNvSpPr/>
+          <p:nvPr/>
+        </p:nvSpPr>
+        <p:spPr>
+          <a:xfrm>
+            <a:off x="2876550" y="9429750"/>
+            <a:ext cx="114300" cy="114300"/>
+          </a:xfrm>
+          <a:prstGeom prst="ellipse">
+            <a:avLst/>
+          </a:prstGeom>
+          <a:solidFill>
+            <a:srgbClr val="F3EEE3"/>
+          </a:solidFill>
+          <a:ln w="19050">
+            <a:solidFill>
+              <a:srgbClr val="8A867C"/>
+            </a:solidFill>
+            <a:prstDash val="solid"/>
+          </a:ln>
+        </p:spPr>
+      </p:sp>
+      <p:sp>
+        <p:nvSpPr>
+          <p:cNvPr id="21" name="Shape 19"/>
+          <p:cNvSpPr/>
+          <p:nvPr/>
+        </p:nvSpPr>
+        <p:spPr>
+          <a:xfrm>
+            <a:off x="3200400" y="9429750"/>
+            <a:ext cx="114300" cy="114300"/>
+          </a:xfrm>
+          <a:prstGeom prst="ellipse">
+            <a:avLst/>
+          </a:prstGeom>
+          <a:solidFill>
+            <a:srgbClr val="F3EEE3"/>
+          </a:solidFill>
+          <a:ln w="19050">
+            <a:solidFill>
+              <a:srgbClr val="8A867C"/>
+            </a:solidFill>
+            <a:prstDash val="solid"/>
+          </a:ln>
+        </p:spPr>
+      </p:sp>
+      <p:sp>
+        <p:nvSpPr>
+          <p:cNvPr id="22" name="Shape 20"/>
+          <p:cNvSpPr/>
+          <p:nvPr/>
+        </p:nvSpPr>
+        <p:spPr>
+          <a:xfrm>
+            <a:off x="3524250" y="9429750"/>
+            <a:ext cx="114300" cy="114300"/>
+          </a:xfrm>
+          <a:prstGeom prst="ellipse">
+            <a:avLst/>
+          </a:prstGeom>
+          <a:solidFill>
+            <a:srgbClr val="F3EEE3"/>
+          </a:solidFill>
+          <a:ln w="19050">
+            <a:solidFill>
+              <a:srgbClr val="8A867C"/>
+            </a:solidFill>
+            <a:prstDash val="solid"/>
+          </a:ln>
+        </p:spPr>
+      </p:sp>
+      <p:sp>
+        <p:nvSpPr>
+          <p:cNvPr id="23" name="Shape 21"/>
+          <p:cNvSpPr/>
+          <p:nvPr/>
+        </p:nvSpPr>
+        <p:spPr>
+          <a:xfrm>
+            <a:off x="3848100" y="9429750"/>
+            <a:ext cx="114300" cy="114300"/>
+          </a:xfrm>
+          <a:prstGeom prst="ellipse">
+            <a:avLst/>
+          </a:prstGeom>
+          <a:solidFill>
+            <a:srgbClr val="F3EEE3"/>
+          </a:solidFill>
+          <a:ln w="19050">
+            <a:solidFill>
+              <a:srgbClr val="8A867C"/>
+            </a:solidFill>
+            <a:prstDash val="solid"/>
+          </a:ln>
+        </p:spPr>
+      </p:sp>
+      <p:sp>
+        <p:nvSpPr>
+          <p:cNvPr id="24" name="Text 22"/>
+          <p:cNvSpPr/>
+          <p:nvPr/>
+        </p:nvSpPr>
+        <p:spPr>
+          <a:xfrm>
+            <a:off x="914400" y="9715500"/>
+            <a:ext cx="6667500" cy="285750"/>
+          </a:xfrm>
+          <a:prstGeom prst="rect">
+            <a:avLst/>
+          </a:prstGeom>
+          <a:noFill/>
+          <a:ln/>
+        </p:spPr>
+        <p:txBody>
+          <a:bodyPr wrap="square" lIns="0" tIns="0" rIns="0" bIns="0" rtlCol="0" anchor="t"/>
+          <a:lstStyle/>
+          <a:p>
+            <a:pPr algn="l" indent="0" marL="0">
+              <a:buNone/>
+            </a:pPr>
+            <a:r>
               <a:rPr lang="en-US" sz="1650" dirty="0" spc="-12" kern="0">
                 <a:solidFill>
                   <a:srgbClr val="6B6A66"/>
@@ -9572,7 +9798,7 @@
       </p:sp>
       <p:sp>
         <p:nvSpPr>
-          <p:cNvPr id="24" name="Shape 22"/>
+          <p:cNvPr id="25" name="Shape 23"/>
           <p:cNvSpPr/>
           <p:nvPr/>
         </p:nvSpPr>
@@ -9596,7 +9822,7 @@
       </p:sp>
       <p:pic>
         <p:nvPicPr>
-          <p:cNvPr id="25" name="Moda image moda-export-watermark-6cf4adf1-f49a-4e1a-8bb3-b0bbe2c2d79e" descr="">    </p:cNvPr>
+          <p:cNvPr id="26" name="Moda image moda-export-watermark-6cf4adf1-f49a-4e1a-8bb3-b0bbe2c2d79e" descr="">    </p:cNvPr>
           <p:cNvPicPr>
             <a:picLocks noChangeAspect="1"/>
           </p:cNvPicPr>

</xml_diff>